<commit_message>
Diaporama « Apprendre ! » : 4e clé « Dormir »
Co-Authored-By: Claude Opus 5.5 <noreply@anthropic.com>
Claude-Session: https://claude.ai/code/session_0129JW42cTcgCKHyg57ktSfQ
</commit_message>
<xml_diff>
--- a/assets/fichiers/apprendre-diaporama.pptx
+++ b/assets/fichiers/apprendre-diaporama.pptx
@@ -124,7 +124,7 @@
   <p:extLst>
     <p:ext uri="{521415D9-36F7-43E2-AB2F-B90AF26B5E84}">
       <p14:sectionLst xmlns:p14="http://schemas.microsoft.com/office/powerpoint/2010/main">
-        <p14:section name="Introduction" id="{6c25ed1c-77b8-ff3d-b1ca-73d1e6613d01}">
+        <p14:section name="Introduction" id="{32c7678f-6296-bb1e-f861-c3f1d83a50bd}">
           <p14:sldIdLst>
             <p14:sldId id="256"/>
             <p14:sldId id="257"/>
@@ -133,14 +133,14 @@
             <p14:sldId id="260"/>
           </p14:sldIdLst>
         </p14:section>
-        <p14:section name="Bien apprendre" id="{81cb6283-daf9-ab4d-16bc-7d924f17c7d4}">
+        <p14:section name="Bien apprendre" id="{34515012-b24c-1c94-ab4f-b838b9fb164a}">
           <p14:sldIdLst>
             <p14:sldId id="261"/>
             <p14:sldId id="262"/>
             <p14:sldId id="263"/>
           </p14:sldIdLst>
         </p14:section>
-        <p14:section name="Répéter" id="{a60b6984-90b3-28a9-375e-0f7263d8a56e}">
+        <p14:section name="Répéter" id="{036ee98f-f5cf-6e8d-30bd-ade0434407af}">
           <p14:sldIdLst>
             <p14:sldId id="264"/>
             <p14:sldId id="265"/>
@@ -148,7 +148,7 @@
             <p14:sldId id="267"/>
           </p14:sldIdLst>
         </p14:section>
-        <p14:section name="Les erreurs" id="{9c5a804c-7ca1-3a1b-6b8b-113bf6f442e5}">
+        <p14:section name="Les erreurs" id="{648e4703-41f9-d0bf-173c-1ef32a20c33a}">
           <p14:sldIdLst>
             <p14:sldId id="268"/>
             <p14:sldId id="269"/>
@@ -156,12 +156,12 @@
             <p14:sldId id="271"/>
           </p14:sldIdLst>
         </p14:section>
-        <p14:section name="Comprendre" id="{f17f06ee-b182-3fb8-33d6-c7fdfb548168}">
+        <p14:section name="Comprendre" id="{9ca7b84a-5c64-f526-b695-a8d0e2129ec3}">
           <p14:sldIdLst>
             <p14:sldId id="272"/>
           </p14:sldIdLst>
         </p14:section>
-        <p14:section name="Bilan" id="{fd869eca-441a-9c66-a517-7fc03053d555}">
+        <p14:section name="Bilan" id="{56c66cc1-bf1e-2338-86ec-a9ae67e3c13f}">
           <p14:sldIdLst>
             <p14:sldId id="273"/>
           </p14:sldIdLst>
@@ -10297,7 +10297,7 @@
                   <a:schemeClr val="tx2"/>
                 </a:solidFill>
               </a:rPr>
-              <a:t>Refaire et dormir</a:t>
+              <a:t>Dormir</a:t>
             </a:r>
             <a:endParaRPr lang="en-US" sz="2400" dirty="0"/>
           </a:p>
@@ -10333,7 +10333,7 @@
                   <a:schemeClr val="tx1"/>
                 </a:solidFill>
               </a:rPr>
-              <a:t>Je refais un peu chaque jour de mémoire et je dors bien pour tout ranger.</a:t>
+              <a:t>Je dors bien pour tout ranger pendant que je dors.</a:t>
             </a:r>
             <a:endParaRPr lang="en-US" sz="1700" dirty="0"/>
           </a:p>

</xml_diff>

<commit_message>
Diapo 9 : « Pour bien fonctionner, le cerveau oublie » + illustration Canva
</commit_message>
<xml_diff>
--- a/assets/fichiers/apprendre-diaporama.pptx
+++ b/assets/fichiers/apprendre-diaporama.pptx
@@ -11086,7 +11086,7 @@
               <a:buNone/>
             </a:pPr>
             <a:r>
-              <a:rPr lang="en-US" sz="3000" dirty="0">
+              <a:rPr lang="en-US" sz="2600" dirty="0">
                 <a:solidFill>
                   <a:srgbClr val="1E2B22"/>
                 </a:solidFill>
@@ -11094,16 +11094,16 @@
                 <a:ea typeface="Cambria" pitchFamily="34" charset="-122"/>
                 <a:cs typeface="Cambria" pitchFamily="34" charset="-120"/>
               </a:rPr>
-              <a:t>LE CERVEAU EST</a:t>
-            </a:r>
-            <a:endParaRPr lang="en-US" sz="3000" dirty="0"/>
+              <a:t>POUR BIEN FONCTIONNER,</a:t>
+            </a:r>
+            <a:endParaRPr lang="en-US" sz="2600" dirty="0"/>
           </a:p>
           <a:p>
             <a:pPr algn="ctr" indent="0" marL="0">
               <a:buNone/>
             </a:pPr>
             <a:r>
-              <a:rPr lang="en-US" sz="3000" dirty="0">
+              <a:rPr lang="en-US" sz="2600" dirty="0">
                 <a:solidFill>
                   <a:srgbClr val="1E2B22"/>
                 </a:solidFill>
@@ -11111,9 +11111,9 @@
                 <a:ea typeface="Cambria" pitchFamily="34" charset="-122"/>
                 <a:cs typeface="Cambria" pitchFamily="34" charset="-120"/>
               </a:rPr>
-              <a:t>FAIT POUR OUBLIER</a:t>
-            </a:r>
-            <a:endParaRPr lang="en-US" sz="3000" dirty="0"/>
+              <a:t>LE CERVEAU OUBLIE</a:t>
+            </a:r>
+            <a:endParaRPr lang="en-US" sz="2600" dirty="0"/>
           </a:p>
         </p:txBody>
       </p:sp>
@@ -11181,7 +11181,7 @@
       </p:sp>
       <p:pic>
         <p:nvPicPr>
-          <p:cNvPr id="6" name="Tête qui réfléchit" descr="Une tête qui réfléchit">    </p:cNvPr>
+          <p:cNvPr id="6" name="Cerveau qui oublie" descr="Un cerveau souriant qui laisse s’envoler des souvenirs">    </p:cNvPr>
           <p:cNvPicPr>
             <a:picLocks noChangeAspect="1"/>
           </p:cNvPicPr>

</xml_diff>

<commit_message>
Diapo 9 : « Recommencer en faisant appel à ta mémoire »
Co-Authored-By: Claude Opus 5.5 <noreply@anthropic.com>
Claude-Session: https://claude.ai/code/session_0129JW45WodWCaGbeJ2fS43e
</commit_message>
<xml_diff>
--- a/assets/fichiers/apprendre-diaporama.pptx
+++ b/assets/fichiers/apprendre-diaporama.pptx
@@ -11022,7 +11022,7 @@
                   <a:schemeClr val="tx2"/>
                 </a:solidFill>
               </a:rPr>
-              <a:t>Refaire en faisant appel à sa mémoire</a:t>
+              <a:t>Recommencer en faisant appel à ta mémoire</a:t>
             </a:r>
             <a:endParaRPr lang="en-US" sz="3600" dirty="0"/>
           </a:p>
@@ -11153,7 +11153,7 @@
                 <a:ea typeface="Cambria" pitchFamily="34" charset="-122"/>
                 <a:cs typeface="Cambria" pitchFamily="34" charset="-120"/>
               </a:rPr>
-              <a:t>Refaire en faisant toujours appel à sa mémoire</a:t>
+              <a:t>Recommencer en faisant toujours appel à ta mémoire</a:t>
             </a:r>
             <a:endParaRPr lang="en-US" sz="2600" dirty="0"/>
           </a:p>

</xml_diff>